<commit_message>
Slides: number the five deployment risks separately (sd-13-020)
Co-Authored-By: Claude Sonnet 5.5 <noreply@anthropic.com>
Claude-Session: https://claude.ai/code/session_01EhxTYrCJpuk4mcqCLwPdds
</commit_message>
<xml_diff>
--- a/system-design-101/vi/lessons/sd-13-020/slides/sd-13-020.pptx
+++ b/system-design-101/vi/lessons/sd-13-020/slides/sd-13-020.pptx
@@ -2033,7 +2033,7 @@
         <p:spPr>
           <a:xfrm>
             <a:off x="914400" y="5905500"/>
-            <a:ext cx="3886200" cy="2381250"/>
+            <a:ext cx="3048000" cy="2381250"/>
           </a:xfrm>
           <a:prstGeom prst="roundRect">
             <a:avLst>
@@ -2099,7 +2099,7 @@
         <p:spPr>
           <a:xfrm>
             <a:off x="1181100" y="6572250"/>
-            <a:ext cx="3352800" cy="1524000"/>
+            <a:ext cx="2514600" cy="1524000"/>
           </a:xfrm>
           <a:prstGeom prst="rect">
             <a:avLst/>
@@ -2115,7 +2115,7 @@
               <a:buNone/>
             </a:pPr>
             <a:r>
-              <a:rPr lang="en-US" sz="2400" dirty="0" spc="-22" kern="0">
+              <a:rPr lang="en-US" sz="2250" dirty="0" spc="-18" kern="0">
                 <a:solidFill>
                   <a:srgbClr val="7C93FF"/>
                 </a:solidFill>
@@ -2126,7 +2126,7 @@
               <a:t>Lỗi</a:t>
             </a:r>
             <a:r>
-              <a:rPr lang="en-US" sz="2400" dirty="0" spc="1" kern="0">
+              <a:rPr lang="en-US" sz="2250" dirty="0" spc="2" kern="0">
                 <a:solidFill>
                   <a:srgbClr val="7C93FF"/>
                 </a:solidFill>
@@ -2137,7 +2137,7 @@
               <a:t> chỉ</a:t>
             </a:r>
             <a:r>
-              <a:rPr lang="en-US" sz="2400" dirty="0" spc="-6" kern="0">
+              <a:rPr lang="en-US" sz="2250" dirty="0" spc="-6" kern="0">
                 <a:solidFill>
                   <a:srgbClr val="7C93FF"/>
                 </a:solidFill>
@@ -2148,7 +2148,7 @@
               <a:t> lộ</a:t>
             </a:r>
             <a:r>
-              <a:rPr lang="en-US" sz="2400" dirty="0" spc="0" kern="0">
+              <a:rPr lang="en-US" sz="2250" dirty="0" spc="1" kern="0">
                 <a:solidFill>
                   <a:srgbClr val="7C93FF"/>
                 </a:solidFill>
@@ -2159,7 +2159,7 @@
               <a:t> ở</a:t>
             </a:r>
             <a:r>
-              <a:rPr lang="en-US" sz="2400" dirty="0" spc="-1" kern="0">
+              <a:rPr lang="en-US" sz="2250" dirty="0" spc="3" kern="0">
                 <a:solidFill>
                   <a:srgbClr val="7C93FF"/>
                 </a:solidFill>
@@ -2170,7 +2170,7 @@
               <a:t> tải</a:t>
             </a:r>
             <a:r>
-              <a:rPr lang="en-US" sz="2400" dirty="0" spc="-4" kern="0">
+              <a:rPr lang="en-US" sz="2250" dirty="0" spc="-2" kern="0">
                 <a:solidFill>
                   <a:srgbClr val="7C93FF"/>
                 </a:solidFill>
@@ -2178,64 +2178,9 @@
                 <a:ea typeface="Be Vietnam Pro ExtraBold" pitchFamily="34" charset="-122"/>
                 <a:cs typeface="Be Vietnam Pro ExtraBold" pitchFamily="34" charset="-120"/>
               </a:rPr>
-              <a:t> thật,</a:t>
-            </a:r>
-            <a:r>
-              <a:rPr lang="en-US" sz="2400" dirty="0" spc="-1" kern="0">
-                <a:solidFill>
-                  <a:srgbClr val="7C93FF"/>
-                </a:solidFill>
-                <a:latin typeface="Be Vietnam Pro ExtraBold" pitchFamily="34" charset="0"/>
-                <a:ea typeface="Be Vietnam Pro ExtraBold" pitchFamily="34" charset="-122"/>
-                <a:cs typeface="Be Vietnam Pro ExtraBold" pitchFamily="34" charset="-120"/>
-              </a:rPr>
-              <a:t> hai</a:t>
-            </a:r>
-            <a:r>
-              <a:rPr lang="en-US" sz="2400" dirty="0" spc="-5" kern="0">
-                <a:solidFill>
-                  <a:srgbClr val="7C93FF"/>
-                </a:solidFill>
-                <a:latin typeface="Be Vietnam Pro ExtraBold" pitchFamily="34" charset="0"/>
-                <a:ea typeface="Be Vietnam Pro ExtraBold" pitchFamily="34" charset="-122"/>
-                <a:cs typeface="Be Vietnam Pro ExtraBold" pitchFamily="34" charset="-120"/>
-              </a:rPr>
-              <a:t> phiên</a:t>
-            </a:r>
-            <a:r>
-              <a:rPr lang="en-US" sz="2400" dirty="0" spc="-1" kern="0">
-                <a:solidFill>
-                  <a:srgbClr val="7C93FF"/>
-                </a:solidFill>
-                <a:latin typeface="Be Vietnam Pro ExtraBold" pitchFamily="34" charset="0"/>
-                <a:ea typeface="Be Vietnam Pro ExtraBold" pitchFamily="34" charset="-122"/>
-                <a:cs typeface="Be Vietnam Pro ExtraBold" pitchFamily="34" charset="-120"/>
-              </a:rPr>
-              <a:t> bản</a:t>
-            </a:r>
-            <a:r>
-              <a:rPr lang="en-US" sz="2400" dirty="0" spc="0" kern="0">
-                <a:solidFill>
-                  <a:srgbClr val="7C93FF"/>
-                </a:solidFill>
-                <a:latin typeface="Be Vietnam Pro ExtraBold" pitchFamily="34" charset="0"/>
-                <a:ea typeface="Be Vietnam Pro ExtraBold" pitchFamily="34" charset="-122"/>
-                <a:cs typeface="Be Vietnam Pro ExtraBold" pitchFamily="34" charset="-120"/>
-              </a:rPr>
-              <a:t> gặp</a:t>
-            </a:r>
-            <a:r>
-              <a:rPr lang="en-US" sz="2400" dirty="0" spc="2" kern="0">
-                <a:solidFill>
-                  <a:srgbClr val="7C93FF"/>
-                </a:solidFill>
-                <a:latin typeface="Be Vietnam Pro ExtraBold" pitchFamily="34" charset="0"/>
-                <a:ea typeface="Be Vietnam Pro ExtraBold" pitchFamily="34" charset="-122"/>
-                <a:cs typeface="Be Vietnam Pro ExtraBold" pitchFamily="34" charset="-120"/>
-              </a:rPr>
-              <a:t> nhau</a:t>
-            </a:r>
-            <a:endParaRPr lang="en-US" sz="2400" dirty="0"/>
+              <a:t> thật</a:t>
+            </a:r>
+            <a:endParaRPr lang="en-US" sz="2250" dirty="0"/>
           </a:p>
         </p:txBody>
       </p:sp>
@@ -2247,8 +2192,8 @@
         </p:nvSpPr>
         <p:spPr>
           <a:xfrm>
-            <a:off x="5105400" y="5905500"/>
-            <a:ext cx="3886200" cy="2381250"/>
+            <a:off x="4267200" y="5905500"/>
+            <a:ext cx="3048000" cy="2381250"/>
           </a:xfrm>
           <a:prstGeom prst="roundRect">
             <a:avLst>
@@ -2260,7 +2205,7 @@
           </a:solidFill>
           <a:ln w="28575">
             <a:solidFill>
-              <a:srgbClr val="FFB454"/>
+              <a:srgbClr val="7C93FF"/>
             </a:solidFill>
             <a:prstDash val="solid"/>
           </a:ln>
@@ -2274,7 +2219,7 @@
         </p:nvSpPr>
         <p:spPr>
           <a:xfrm>
-            <a:off x="5372100" y="6096000"/>
+            <a:off x="4533900" y="6096000"/>
             <a:ext cx="1905000" cy="381000"/>
           </a:xfrm>
           <a:prstGeom prst="rect">
@@ -2293,7 +2238,7 @@
             <a:r>
               <a:rPr lang="en-US" sz="1950" b="1" dirty="0" spc="-5" kern="0">
                 <a:solidFill>
-                  <a:srgbClr val="FFB454"/>
+                  <a:srgbClr val="7C93FF"/>
                 </a:solidFill>
                 <a:latin typeface="Be Vietnam Pro" pitchFamily="34" charset="0"/>
                 <a:ea typeface="Be Vietnam Pro" pitchFamily="34" charset="-122"/>
@@ -2313,8 +2258,8 @@
         </p:nvSpPr>
         <p:spPr>
           <a:xfrm>
-            <a:off x="5372100" y="6572250"/>
-            <a:ext cx="3352800" cy="1524000"/>
+            <a:off x="4533900" y="6572250"/>
+            <a:ext cx="2514600" cy="1524000"/>
           </a:xfrm>
           <a:prstGeom prst="rect">
             <a:avLst/>
@@ -2330,31 +2275,31 @@
               <a:buNone/>
             </a:pPr>
             <a:r>
-              <a:rPr lang="en-US" sz="2400" dirty="0" spc="-14" kern="0">
-                <a:solidFill>
-                  <a:srgbClr val="FFB454"/>
+              <a:rPr lang="en-US" sz="2250" dirty="0" spc="0" kern="0">
+                <a:solidFill>
+                  <a:srgbClr val="7C93FF"/>
                 </a:solidFill>
                 <a:latin typeface="Be Vietnam Pro ExtraBold" pitchFamily="34" charset="0"/>
                 <a:ea typeface="Be Vietnam Pro ExtraBold" pitchFamily="34" charset="-122"/>
                 <a:cs typeface="Be Vietnam Pro ExtraBold" pitchFamily="34" charset="-120"/>
               </a:rPr>
-              <a:t>Không</a:t>
-            </a:r>
-            <a:r>
-              <a:rPr lang="en-US" sz="2400" dirty="0" spc="-4" kern="0">
-                <a:solidFill>
-                  <a:srgbClr val="FFB454"/>
+              <a:t>Hai</a:t>
+            </a:r>
+            <a:r>
+              <a:rPr lang="en-US" sz="2250" dirty="0" spc="-5" kern="0">
+                <a:solidFill>
+                  <a:srgbClr val="7C93FF"/>
                 </a:solidFill>
                 <a:latin typeface="Be Vietnam Pro ExtraBold" pitchFamily="34" charset="0"/>
                 <a:ea typeface="Be Vietnam Pro ExtraBold" pitchFamily="34" charset="-122"/>
                 <a:cs typeface="Be Vietnam Pro ExtraBold" pitchFamily="34" charset="-120"/>
               </a:rPr>
-              <a:t> biết</a:t>
-            </a:r>
-            <a:r>
-              <a:rPr lang="en-US" sz="2400" dirty="0" spc="-1" kern="0">
-                <a:solidFill>
-                  <a:srgbClr val="FFB454"/>
+              <a:t> phiên</a:t>
+            </a:r>
+            <a:r>
+              <a:rPr lang="en-US" sz="2250" dirty="0" spc="3" kern="0">
+                <a:solidFill>
+                  <a:srgbClr val="7C93FF"/>
                 </a:solidFill>
                 <a:latin typeface="Be Vietnam Pro ExtraBold" pitchFamily="34" charset="0"/>
                 <a:ea typeface="Be Vietnam Pro ExtraBold" pitchFamily="34" charset="-122"/>
@@ -2363,50 +2308,28 @@
               <a:t> bản</a:t>
             </a:r>
             <a:r>
-              <a:rPr lang="en-US" sz="2400" dirty="0" spc="2" kern="0">
-                <a:solidFill>
-                  <a:srgbClr val="FFB454"/>
+              <a:rPr lang="en-US" sz="2250" dirty="0" spc="0" kern="0">
+                <a:solidFill>
+                  <a:srgbClr val="7C93FF"/>
                 </a:solidFill>
                 <a:latin typeface="Be Vietnam Pro ExtraBold" pitchFamily="34" charset="0"/>
                 <a:ea typeface="Be Vietnam Pro ExtraBold" pitchFamily="34" charset="-122"/>
                 <a:cs typeface="Be Vietnam Pro ExtraBold" pitchFamily="34" charset="-120"/>
               </a:rPr>
-              <a:t> mới</a:t>
-            </a:r>
-            <a:r>
-              <a:rPr lang="en-US" sz="2400" dirty="0" spc="-11" kern="0">
-                <a:solidFill>
-                  <a:srgbClr val="FFB454"/>
+              <a:t> gặp</a:t>
+            </a:r>
+            <a:r>
+              <a:rPr lang="en-US" sz="2250" dirty="0" spc="4" kern="0">
+                <a:solidFill>
+                  <a:srgbClr val="7C93FF"/>
                 </a:solidFill>
                 <a:latin typeface="Be Vietnam Pro ExtraBold" pitchFamily="34" charset="0"/>
                 <a:ea typeface="Be Vietnam Pro ExtraBold" pitchFamily="34" charset="-122"/>
                 <a:cs typeface="Be Vietnam Pro ExtraBold" pitchFamily="34" charset="-120"/>
               </a:rPr>
-              <a:t> tốt</a:t>
-            </a:r>
-            <a:r>
-              <a:rPr lang="en-US" sz="2400" dirty="0" spc="-7" kern="0">
-                <a:solidFill>
-                  <a:srgbClr val="FFB454"/>
-                </a:solidFill>
-                <a:latin typeface="Be Vietnam Pro ExtraBold" pitchFamily="34" charset="0"/>
-                <a:ea typeface="Be Vietnam Pro ExtraBold" pitchFamily="34" charset="-122"/>
-                <a:cs typeface="Be Vietnam Pro ExtraBold" pitchFamily="34" charset="-120"/>
-              </a:rPr>
-              <a:t> hay</a:t>
-            </a:r>
-            <a:r>
-              <a:rPr lang="en-US" sz="2400" dirty="0" spc="-17" kern="0">
-                <a:solidFill>
-                  <a:srgbClr val="FFB454"/>
-                </a:solidFill>
-                <a:latin typeface="Be Vietnam Pro ExtraBold" pitchFamily="34" charset="0"/>
-                <a:ea typeface="Be Vietnam Pro ExtraBold" pitchFamily="34" charset="-122"/>
-                <a:cs typeface="Be Vietnam Pro ExtraBold" pitchFamily="34" charset="-120"/>
-              </a:rPr>
-              <a:t> xấu</a:t>
-            </a:r>
-            <a:endParaRPr lang="en-US" sz="2400" dirty="0"/>
+              <a:t> nhau</a:t>
+            </a:r>
+            <a:endParaRPr lang="en-US" sz="2250" dirty="0"/>
           </a:p>
         </p:txBody>
       </p:sp>
@@ -2418,8 +2341,8 @@
         </p:nvSpPr>
         <p:spPr>
           <a:xfrm>
-            <a:off x="9296400" y="5905500"/>
-            <a:ext cx="3886200" cy="2381250"/>
+            <a:off x="7620000" y="5905500"/>
+            <a:ext cx="3048000" cy="2381250"/>
           </a:xfrm>
           <a:prstGeom prst="roundRect">
             <a:avLst>
@@ -2431,7 +2354,7 @@
           </a:solidFill>
           <a:ln w="28575">
             <a:solidFill>
-              <a:srgbClr val="3DD6A0"/>
+              <a:srgbClr val="FFB454"/>
             </a:solidFill>
             <a:prstDash val="solid"/>
           </a:ln>
@@ -2445,7 +2368,7 @@
         </p:nvSpPr>
         <p:spPr>
           <a:xfrm>
-            <a:off x="9563100" y="6096000"/>
+            <a:off x="7886700" y="6096000"/>
             <a:ext cx="1905000" cy="381000"/>
           </a:xfrm>
           <a:prstGeom prst="rect">
@@ -2464,7 +2387,7 @@
             <a:r>
               <a:rPr lang="en-US" sz="1950" b="1" dirty="0" spc="1" kern="0">
                 <a:solidFill>
-                  <a:srgbClr val="3DD6A0"/>
+                  <a:srgbClr val="FFB454"/>
                 </a:solidFill>
                 <a:latin typeface="Be Vietnam Pro" pitchFamily="34" charset="0"/>
                 <a:ea typeface="Be Vietnam Pro" pitchFamily="34" charset="-122"/>
@@ -2484,8 +2407,8 @@
         </p:nvSpPr>
         <p:spPr>
           <a:xfrm>
-            <a:off x="9563100" y="6572250"/>
-            <a:ext cx="3352800" cy="1524000"/>
+            <a:off x="7886700" y="6572250"/>
+            <a:ext cx="2514600" cy="1524000"/>
           </a:xfrm>
           <a:prstGeom prst="rect">
             <a:avLst/>
@@ -2501,50 +2424,83 @@
               <a:buNone/>
             </a:pPr>
             <a:r>
-              <a:rPr lang="en-US" sz="2400" dirty="0" spc="-45" kern="0">
-                <a:solidFill>
-                  <a:srgbClr val="3DD6A0"/>
+              <a:rPr lang="en-US" sz="2250" dirty="0" spc="-11" kern="0">
+                <a:solidFill>
+                  <a:srgbClr val="FFB454"/>
                 </a:solidFill>
                 <a:latin typeface="Be Vietnam Pro ExtraBold" pitchFamily="34" charset="0"/>
                 <a:ea typeface="Be Vietnam Pro ExtraBold" pitchFamily="34" charset="-122"/>
                 <a:cs typeface="Be Vietnam Pro ExtraBold" pitchFamily="34" charset="-120"/>
               </a:rPr>
-              <a:t>Rút</a:t>
-            </a:r>
-            <a:r>
-              <a:rPr lang="en-US" sz="2400" dirty="0" spc="-2" kern="0">
-                <a:solidFill>
-                  <a:srgbClr val="3DD6A0"/>
+              <a:t>Không</a:t>
+            </a:r>
+            <a:r>
+              <a:rPr lang="en-US" sz="2250" dirty="0" spc="-3" kern="0">
+                <a:solidFill>
+                  <a:srgbClr val="FFB454"/>
                 </a:solidFill>
                 <a:latin typeface="Be Vietnam Pro ExtraBold" pitchFamily="34" charset="0"/>
                 <a:ea typeface="Be Vietnam Pro ExtraBold" pitchFamily="34" charset="-122"/>
                 <a:cs typeface="Be Vietnam Pro ExtraBold" pitchFamily="34" charset="-120"/>
               </a:rPr>
-              <a:t> lại</a:t>
-            </a:r>
-            <a:r>
-              <a:rPr lang="en-US" sz="2400" dirty="0" spc="3" kern="0">
-                <a:solidFill>
-                  <a:srgbClr val="3DD6A0"/>
+              <a:t> biết</a:t>
+            </a:r>
+            <a:r>
+              <a:rPr lang="en-US" sz="2250" dirty="0" spc="2" kern="0">
+                <a:solidFill>
+                  <a:srgbClr val="FFB454"/>
                 </a:solidFill>
                 <a:latin typeface="Be Vietnam Pro ExtraBold" pitchFamily="34" charset="0"/>
                 <a:ea typeface="Be Vietnam Pro ExtraBold" pitchFamily="34" charset="-122"/>
                 <a:cs typeface="Be Vietnam Pro ExtraBold" pitchFamily="34" charset="-120"/>
               </a:rPr>
-              <a:t> quá</a:t>
-            </a:r>
-            <a:r>
-              <a:rPr lang="en-US" sz="2400" dirty="0" spc="0" kern="0">
-                <a:solidFill>
-                  <a:srgbClr val="3DD6A0"/>
+              <a:t> bản</a:t>
+            </a:r>
+            <a:r>
+              <a:rPr lang="en-US" sz="2250" dirty="0" spc="5" kern="0">
+                <a:solidFill>
+                  <a:srgbClr val="FFB454"/>
                 </a:solidFill>
                 <a:latin typeface="Be Vietnam Pro ExtraBold" pitchFamily="34" charset="0"/>
                 <a:ea typeface="Be Vietnam Pro ExtraBold" pitchFamily="34" charset="-122"/>
                 <a:cs typeface="Be Vietnam Pro ExtraBold" pitchFamily="34" charset="-120"/>
               </a:rPr>
-              <a:t> chậm</a:t>
-            </a:r>
-            <a:endParaRPr lang="en-US" sz="2400" dirty="0"/>
+              <a:t> mới</a:t>
+            </a:r>
+            <a:r>
+              <a:rPr lang="en-US" sz="2250" dirty="0" spc="-5" kern="0">
+                <a:solidFill>
+                  <a:srgbClr val="FFB454"/>
+                </a:solidFill>
+                <a:latin typeface="Be Vietnam Pro ExtraBold" pitchFamily="34" charset="0"/>
+                <a:ea typeface="Be Vietnam Pro ExtraBold" pitchFamily="34" charset="-122"/>
+                <a:cs typeface="Be Vietnam Pro ExtraBold" pitchFamily="34" charset="-120"/>
+              </a:rPr>
+              <a:t> tốt</a:t>
+            </a:r>
+            <a:r>
+              <a:rPr lang="en-US" sz="2250" dirty="0" spc="-7" kern="0">
+                <a:solidFill>
+                  <a:srgbClr val="FFB454"/>
+                </a:solidFill>
+                <a:latin typeface="Be Vietnam Pro ExtraBold" pitchFamily="34" charset="0"/>
+                <a:ea typeface="Be Vietnam Pro ExtraBold" pitchFamily="34" charset="-122"/>
+                <a:cs typeface="Be Vietnam Pro ExtraBold" pitchFamily="34" charset="-120"/>
+              </a:rPr>
+              <a:t> hay</a:t>
+            </a:r>
+            <a:r>
+              <a:rPr lang="en-US" sz="2250" dirty="0" spc="-14" kern="0">
+                <a:solidFill>
+                  <a:srgbClr val="FFB454"/>
+                </a:solidFill>
+                <a:latin typeface="Be Vietnam Pro ExtraBold" pitchFamily="34" charset="0"/>
+                <a:ea typeface="Be Vietnam Pro ExtraBold" pitchFamily="34" charset="-122"/>
+                <a:cs typeface="Be Vietnam Pro ExtraBold" pitchFamily="34" charset="-120"/>
+              </a:rPr>
+              <a:t> xấu</a:t>
+            </a:r>
+            <a:endParaRPr lang="en-US" sz="2250" dirty="0"/>
           </a:p>
         </p:txBody>
       </p:sp>
@@ -2556,8 +2512,8 @@
         </p:nvSpPr>
         <p:spPr>
           <a:xfrm>
-            <a:off x="13487400" y="5905500"/>
-            <a:ext cx="3886200" cy="2381250"/>
+            <a:off x="10972800" y="5905500"/>
+            <a:ext cx="3048000" cy="2381250"/>
           </a:xfrm>
           <a:prstGeom prst="roundRect">
             <a:avLst>
@@ -2569,7 +2525,7 @@
           </a:solidFill>
           <a:ln w="28575">
             <a:solidFill>
-              <a:srgbClr val="FF6A4D"/>
+              <a:srgbClr val="3DD6A0"/>
             </a:solidFill>
             <a:prstDash val="solid"/>
           </a:ln>
@@ -2583,7 +2539,7 @@
         </p:nvSpPr>
         <p:spPr>
           <a:xfrm>
-            <a:off x="13754100" y="6096000"/>
+            <a:off x="11239500" y="6096000"/>
             <a:ext cx="1905000" cy="381000"/>
           </a:xfrm>
           <a:prstGeom prst="rect">
@@ -2602,7 +2558,7 @@
             <a:r>
               <a:rPr lang="en-US" sz="1950" b="1" dirty="0" spc="4" kern="0">
                 <a:solidFill>
-                  <a:srgbClr val="FF6A4D"/>
+                  <a:srgbClr val="3DD6A0"/>
                 </a:solidFill>
                 <a:latin typeface="Be Vietnam Pro" pitchFamily="34" charset="0"/>
                 <a:ea typeface="Be Vietnam Pro" pitchFamily="34" charset="-122"/>
@@ -2622,8 +2578,8 @@
         </p:nvSpPr>
         <p:spPr>
           <a:xfrm>
-            <a:off x="13754100" y="6572250"/>
-            <a:ext cx="3352800" cy="1524000"/>
+            <a:off x="11239500" y="6572250"/>
+            <a:ext cx="2514600" cy="1524000"/>
           </a:xfrm>
           <a:prstGeom prst="rect">
             <a:avLst/>
@@ -2639,51 +2595,145 @@
               <a:buNone/>
             </a:pPr>
             <a:r>
-              <a:rPr lang="en-US" sz="2400" dirty="0" spc="-8" kern="0">
-                <a:solidFill>
-                  <a:srgbClr val="FF6A4D"/>
+              <a:rPr lang="en-US" sz="2250" dirty="0" spc="-44" kern="0">
+                <a:solidFill>
+                  <a:srgbClr val="3DD6A0"/>
                 </a:solidFill>
                 <a:latin typeface="Be Vietnam Pro ExtraBold" pitchFamily="34" charset="0"/>
                 <a:ea typeface="Be Vietnam Pro ExtraBold" pitchFamily="34" charset="-122"/>
                 <a:cs typeface="Be Vietnam Pro ExtraBold" pitchFamily="34" charset="-120"/>
               </a:rPr>
-              <a:t>Thay</a:t>
-            </a:r>
-            <a:r>
-              <a:rPr lang="en-US" sz="2400" dirty="0" spc="1" kern="0">
-                <a:solidFill>
-                  <a:srgbClr val="FF6A4D"/>
+              <a:t>Rút</a:t>
+            </a:r>
+            <a:r>
+              <a:rPr lang="en-US" sz="2250" dirty="0" spc="-1" kern="0">
+                <a:solidFill>
+                  <a:srgbClr val="3DD6A0"/>
                 </a:solidFill>
                 <a:latin typeface="Be Vietnam Pro ExtraBold" pitchFamily="34" charset="0"/>
                 <a:ea typeface="Be Vietnam Pro ExtraBold" pitchFamily="34" charset="-122"/>
                 <a:cs typeface="Be Vietnam Pro ExtraBold" pitchFamily="34" charset="-120"/>
               </a:rPr>
-              <a:t> đổi</a:t>
-            </a:r>
-            <a:r>
-              <a:rPr lang="en-US" sz="2400" dirty="0" spc="-4" kern="0">
-                <a:solidFill>
-                  <a:srgbClr val="FF6A4D"/>
+              <a:t> lại</a:t>
+            </a:r>
+            <a:r>
+              <a:rPr lang="en-US" sz="2250" dirty="0" spc="3" kern="0">
+                <a:solidFill>
+                  <a:srgbClr val="3DD6A0"/>
                 </a:solidFill>
                 <a:latin typeface="Be Vietnam Pro ExtraBold" pitchFamily="34" charset="0"/>
                 <a:ea typeface="Be Vietnam Pro ExtraBold" pitchFamily="34" charset="-122"/>
                 <a:cs typeface="Be Vietnam Pro ExtraBold" pitchFamily="34" charset="-120"/>
               </a:rPr>
-              <a:t> gói</a:t>
-            </a:r>
-            <a:r>
-              <a:rPr lang="en-US" sz="2400" dirty="0" spc="2" kern="0">
-                <a:solidFill>
-                  <a:srgbClr val="FF6A4D"/>
+              <a:t> quá</a:t>
+            </a:r>
+            <a:r>
+              <a:rPr lang="en-US" sz="2250" dirty="0" spc="1" kern="0">
+                <a:solidFill>
+                  <a:srgbClr val="3DD6A0"/>
                 </a:solidFill>
                 <a:latin typeface="Be Vietnam Pro ExtraBold" pitchFamily="34" charset="0"/>
                 <a:ea typeface="Be Vietnam Pro ExtraBold" pitchFamily="34" charset="-122"/>
                 <a:cs typeface="Be Vietnam Pro ExtraBold" pitchFamily="34" charset="-120"/>
               </a:rPr>
-              <a:t> quá</a:t>
-            </a:r>
-            <a:r>
-              <a:rPr lang="en-US" sz="2400" dirty="0" spc="-5" kern="0">
+              <a:t> chậm</a:t>
+            </a:r>
+            <a:endParaRPr lang="en-US" sz="2250" dirty="0"/>
+          </a:p>
+        </p:txBody>
+      </p:sp>
+      <p:sp>
+        <p:nvSpPr>
+          <p:cNvPr id="17" name="Shape 15"/>
+          <p:cNvSpPr/>
+          <p:nvPr/>
+        </p:nvSpPr>
+        <p:spPr>
+          <a:xfrm>
+            <a:off x="14325600" y="5905500"/>
+            <a:ext cx="3048000" cy="2381250"/>
+          </a:xfrm>
+          <a:prstGeom prst="roundRect">
+            <a:avLst>
+              <a:gd name="adj" fmla="val 8000"/>
+            </a:avLst>
+          </a:prstGeom>
+          <a:solidFill>
+            <a:srgbClr val="1E212B"/>
+          </a:solidFill>
+          <a:ln w="28575">
+            <a:solidFill>
+              <a:srgbClr val="FF6A4D"/>
+            </a:solidFill>
+            <a:prstDash val="solid"/>
+          </a:ln>
+        </p:spPr>
+      </p:sp>
+      <p:sp>
+        <p:nvSpPr>
+          <p:cNvPr id="18" name="Text 16"/>
+          <p:cNvSpPr/>
+          <p:nvPr/>
+        </p:nvSpPr>
+        <p:spPr>
+          <a:xfrm>
+            <a:off x="14592300" y="6096000"/>
+            <a:ext cx="1905000" cy="381000"/>
+          </a:xfrm>
+          <a:prstGeom prst="rect">
+            <a:avLst/>
+          </a:prstGeom>
+          <a:noFill/>
+          <a:ln/>
+        </p:spPr>
+        <p:txBody>
+          <a:bodyPr wrap="square" lIns="0" tIns="0" rIns="0" bIns="0" rtlCol="0" anchor="t"/>
+          <a:lstStyle/>
+          <a:p>
+            <a:pPr algn="l" indent="0" marL="0">
+              <a:buNone/>
+            </a:pPr>
+            <a:r>
+              <a:rPr lang="en-US" sz="1950" b="1" dirty="0" spc="5" kern="0">
+                <a:solidFill>
+                  <a:srgbClr val="FF6A4D"/>
+                </a:solidFill>
+                <a:latin typeface="Be Vietnam Pro" pitchFamily="34" charset="0"/>
+                <a:ea typeface="Be Vietnam Pro" pitchFamily="34" charset="-122"/>
+                <a:cs typeface="Be Vietnam Pro" pitchFamily="34" charset="-120"/>
+              </a:rPr>
+              <a:t>5</a:t>
+            </a:r>
+            <a:endParaRPr lang="en-US" sz="1950" dirty="0"/>
+          </a:p>
+        </p:txBody>
+      </p:sp>
+      <p:sp>
+        <p:nvSpPr>
+          <p:cNvPr id="19" name="Text 17"/>
+          <p:cNvSpPr/>
+          <p:nvPr/>
+        </p:nvSpPr>
+        <p:spPr>
+          <a:xfrm>
+            <a:off x="14592300" y="6572250"/>
+            <a:ext cx="2514600" cy="1524000"/>
+          </a:xfrm>
+          <a:prstGeom prst="rect">
+            <a:avLst/>
+          </a:prstGeom>
+          <a:noFill/>
+          <a:ln/>
+        </p:spPr>
+        <p:txBody>
+          <a:bodyPr wrap="square" lIns="0" tIns="0" rIns="0" bIns="0" rtlCol="0" anchor="ctr"/>
+          <a:lstStyle/>
+          <a:p>
+            <a:pPr algn="l" indent="0" marL="0">
+              <a:buNone/>
+            </a:pPr>
+            <a:r>
+              <a:rPr lang="en-US" sz="2250" dirty="0" spc="-10" kern="0">
                 <a:solidFill>
                   <a:srgbClr val="FF6A4D"/>
                 </a:solidFill>
@@ -2691,15 +2741,59 @@
                 <a:ea typeface="Be Vietnam Pro ExtraBold" pitchFamily="34" charset="-122"/>
                 <a:cs typeface="Be Vietnam Pro ExtraBold" pitchFamily="34" charset="-120"/>
               </a:rPr>
+              <a:t>Thay</a:t>
+            </a:r>
+            <a:r>
+              <a:rPr lang="en-US" sz="2250" dirty="0" spc="2" kern="0">
+                <a:solidFill>
+                  <a:srgbClr val="FF6A4D"/>
+                </a:solidFill>
+                <a:latin typeface="Be Vietnam Pro ExtraBold" pitchFamily="34" charset="0"/>
+                <a:ea typeface="Be Vietnam Pro ExtraBold" pitchFamily="34" charset="-122"/>
+                <a:cs typeface="Be Vietnam Pro ExtraBold" pitchFamily="34" charset="-120"/>
+              </a:rPr>
+              <a:t> đổi</a:t>
+            </a:r>
+            <a:r>
+              <a:rPr lang="en-US" sz="2250" dirty="0" spc="-3" kern="0">
+                <a:solidFill>
+                  <a:srgbClr val="FF6A4D"/>
+                </a:solidFill>
+                <a:latin typeface="Be Vietnam Pro ExtraBold" pitchFamily="34" charset="0"/>
+                <a:ea typeface="Be Vietnam Pro ExtraBold" pitchFamily="34" charset="-122"/>
+                <a:cs typeface="Be Vietnam Pro ExtraBold" pitchFamily="34" charset="-120"/>
+              </a:rPr>
+              <a:t> gói</a:t>
+            </a:r>
+            <a:r>
+              <a:rPr lang="en-US" sz="2250" dirty="0" spc="3" kern="0">
+                <a:solidFill>
+                  <a:srgbClr val="FF6A4D"/>
+                </a:solidFill>
+                <a:latin typeface="Be Vietnam Pro ExtraBold" pitchFamily="34" charset="0"/>
+                <a:ea typeface="Be Vietnam Pro ExtraBold" pitchFamily="34" charset="-122"/>
+                <a:cs typeface="Be Vietnam Pro ExtraBold" pitchFamily="34" charset="-120"/>
+              </a:rPr>
+              <a:t> quá</a:t>
+            </a:r>
+            <a:r>
+              <a:rPr lang="en-US" sz="2250" dirty="0" spc="-3" kern="0">
+                <a:solidFill>
+                  <a:srgbClr val="FF6A4D"/>
+                </a:solidFill>
+                <a:latin typeface="Be Vietnam Pro ExtraBold" pitchFamily="34" charset="0"/>
+                <a:ea typeface="Be Vietnam Pro ExtraBold" pitchFamily="34" charset="-122"/>
+                <a:cs typeface="Be Vietnam Pro ExtraBold" pitchFamily="34" charset="-120"/>
+              </a:rPr>
               <a:t> lớn</a:t>
             </a:r>
-            <a:endParaRPr lang="en-US" sz="2400" dirty="0"/>
+            <a:endParaRPr lang="en-US" sz="2250" dirty="0"/>
           </a:p>
         </p:txBody>
       </p:sp>
       <p:sp>
         <p:nvSpPr>
-          <p:cNvPr id="17" name="Shape 15"/>
+          <p:cNvPr id="20" name="Shape 18"/>
           <p:cNvSpPr/>
           <p:nvPr/>
         </p:nvSpPr>
@@ -2723,7 +2817,7 @@
       </p:sp>
       <p:pic>
         <p:nvPicPr>
-          <p:cNvPr id="18" name="Moda image moda-export-watermark-884ac12d-6f81-47a4-b357-195d07cb003c" descr="">    </p:cNvPr>
+          <p:cNvPr id="21" name="Moda image moda-export-watermark-884ac12d-6f81-47a4-b357-195d07cb003c" descr="">    </p:cNvPr>
           <p:cNvPicPr>
             <a:picLocks noChangeAspect="1"/>
           </p:cNvPicPr>
@@ -5127,6 +5221,28 @@
               </a:rPr>
               <a:t> 1</a:t>
             </a:r>
+            <a:r>
+              <a:rPr lang="en-US" sz="1950" b="1" spc="249" kern="0" dirty="0">
+                <a:solidFill>
+                  <a:srgbClr val="1F3FD1"/>
+                </a:solidFill>
+                <a:latin typeface="Be Vietnam Pro" pitchFamily="34" charset="0"/>
+                <a:ea typeface="Be Vietnam Pro" pitchFamily="34" charset="-122"/>
+                <a:cs typeface="Be Vietnam Pro" pitchFamily="34" charset="-120"/>
+              </a:rPr>
+              <a:t> VÀ</a:t>
+            </a:r>
+            <a:r>
+              <a:rPr lang="en-US" sz="1950" b="1" spc="297" kern="0" dirty="0">
+                <a:solidFill>
+                  <a:srgbClr val="1F3FD1"/>
+                </a:solidFill>
+                <a:latin typeface="Be Vietnam Pro" pitchFamily="34" charset="0"/>
+                <a:ea typeface="Be Vietnam Pro" pitchFamily="34" charset="-122"/>
+                <a:cs typeface="Be Vietnam Pro" pitchFamily="34" charset="-120"/>
+              </a:rPr>
+              <a:t> 2</a:t>
+            </a:r>
             <a:endParaRPr lang="en-US" sz="1950" dirty="0"/>
           </a:p>
         </p:txBody>
@@ -5261,7 +5377,7 @@
               <a:buNone/>
             </a:pPr>
             <a:r>
-              <a:rPr lang="en-US" sz="1950" b="1" spc="198" kern="0" dirty="0">
+              <a:rPr lang="en-US" sz="1950" b="1" spc="212" kern="0" dirty="0">
                 <a:solidFill>
                   <a:srgbClr val="6B6A66"/>
                 </a:solidFill>
@@ -5269,7 +5385,18 @@
                 <a:ea typeface="Be Vietnam Pro" pitchFamily="34" charset="-122"/>
                 <a:cs typeface="Be Vietnam Pro" pitchFamily="34" charset="-120"/>
               </a:rPr>
-              <a:t>LỖI</a:t>
+              <a:t>RỦI</a:t>
+            </a:r>
+            <a:r>
+              <a:rPr lang="en-US" sz="1950" b="1" spc="205" kern="0" dirty="0">
+                <a:solidFill>
+                  <a:srgbClr val="6B6A66"/>
+                </a:solidFill>
+                <a:latin typeface="Be Vietnam Pro" pitchFamily="34" charset="0"/>
+                <a:ea typeface="Be Vietnam Pro" pitchFamily="34" charset="-122"/>
+                <a:cs typeface="Be Vietnam Pro" pitchFamily="34" charset="-120"/>
+              </a:rPr>
+              <a:t> RO</a:t>
             </a:r>
             <a:r>
               <a:rPr lang="en-US" sz="1950" b="1" spc="226" kern="0" dirty="0">
@@ -5280,10 +5407,43 @@
                 <a:ea typeface="Be Vietnam Pro" pitchFamily="34" charset="-122"/>
                 <a:cs typeface="Be Vietnam Pro" pitchFamily="34" charset="-120"/>
               </a:rPr>
+              <a:t> 1</a:t>
+            </a:r>
+            <a:r>
+              <a:rPr lang="en-US" sz="1950" b="1" spc="221" kern="0" dirty="0">
+                <a:solidFill>
+                  <a:srgbClr val="6B6A66"/>
+                </a:solidFill>
+                <a:latin typeface="Be Vietnam Pro" pitchFamily="34" charset="0"/>
+                <a:ea typeface="Be Vietnam Pro" pitchFamily="34" charset="-122"/>
+                <a:cs typeface="Be Vietnam Pro" pitchFamily="34" charset="-120"/>
+              </a:rPr>
+              <a:t> ·</a:t>
+            </a:r>
+            <a:r>
+              <a:rPr lang="en-US" sz="1950" b="1" spc="205" kern="0" dirty="0">
+                <a:solidFill>
+                  <a:srgbClr val="6B6A66"/>
+                </a:solidFill>
+                <a:latin typeface="Be Vietnam Pro" pitchFamily="34" charset="0"/>
+                <a:ea typeface="Be Vietnam Pro" pitchFamily="34" charset="-122"/>
+                <a:cs typeface="Be Vietnam Pro" pitchFamily="34" charset="-120"/>
+              </a:rPr>
+              <a:t> LỖI</a:t>
+            </a:r>
+            <a:r>
+              <a:rPr lang="en-US" sz="1950" b="1" spc="225" kern="0" dirty="0">
+                <a:solidFill>
+                  <a:srgbClr val="6B6A66"/>
+                </a:solidFill>
+                <a:latin typeface="Be Vietnam Pro" pitchFamily="34" charset="0"/>
+                <a:ea typeface="Be Vietnam Pro" pitchFamily="34" charset="-122"/>
+                <a:cs typeface="Be Vietnam Pro" pitchFamily="34" charset="-120"/>
+              </a:rPr>
               <a:t> CHỈ</a:t>
             </a:r>
             <a:r>
-              <a:rPr lang="en-US" sz="1950" b="1" spc="196" kern="0" dirty="0">
+              <a:rPr lang="en-US" sz="1950" b="1" spc="197" kern="0" dirty="0">
                 <a:solidFill>
                   <a:srgbClr val="6B6A66"/>
                 </a:solidFill>
@@ -5294,7 +5454,7 @@
               <a:t> LỘ</a:t>
             </a:r>
             <a:r>
-              <a:rPr lang="en-US" sz="1950" b="1" spc="226" kern="0" dirty="0">
+              <a:rPr lang="en-US" sz="1950" b="1" spc="225" kern="0" dirty="0">
                 <a:solidFill>
                   <a:srgbClr val="6B6A66"/>
                 </a:solidFill>
@@ -5305,7 +5465,7 @@
               <a:t> Ở</a:t>
             </a:r>
             <a:r>
-              <a:rPr lang="en-US" sz="1950" b="1" spc="177" kern="0" dirty="0">
+              <a:rPr lang="en-US" sz="1950" b="1" spc="178" kern="0" dirty="0">
                 <a:solidFill>
                   <a:srgbClr val="6B6A66"/>
                 </a:solidFill>
@@ -5316,7 +5476,7 @@
               <a:t> TẢI</a:t>
             </a:r>
             <a:r>
-              <a:rPr lang="en-US" sz="1950" b="1" spc="186" kern="0" dirty="0">
+              <a:rPr lang="en-US" sz="1950" b="1" spc="185" kern="0" dirty="0">
                 <a:solidFill>
                   <a:srgbClr val="6B6A66"/>
                 </a:solidFill>
@@ -5567,7 +5727,7 @@
               <a:buNone/>
             </a:pPr>
             <a:r>
-              <a:rPr lang="en-US" sz="1950" b="1" spc="227" kern="0" dirty="0">
+              <a:rPr lang="en-US" sz="1950" b="1" spc="212" kern="0" dirty="0">
                 <a:solidFill>
                   <a:srgbClr val="6B6A66"/>
                 </a:solidFill>
@@ -5575,7 +5735,51 @@
                 <a:ea typeface="Be Vietnam Pro" pitchFamily="34" charset="-122"/>
                 <a:cs typeface="Be Vietnam Pro" pitchFamily="34" charset="-120"/>
               </a:rPr>
-              <a:t>HAI</a:t>
+              <a:t>RỦI</a:t>
+            </a:r>
+            <a:r>
+              <a:rPr lang="en-US" sz="1950" b="1" spc="205" kern="0" dirty="0">
+                <a:solidFill>
+                  <a:srgbClr val="6B6A66"/>
+                </a:solidFill>
+                <a:latin typeface="Be Vietnam Pro" pitchFamily="34" charset="0"/>
+                <a:ea typeface="Be Vietnam Pro" pitchFamily="34" charset="-122"/>
+                <a:cs typeface="Be Vietnam Pro" pitchFamily="34" charset="-120"/>
+              </a:rPr>
+              <a:t> RO</a:t>
+            </a:r>
+            <a:r>
+              <a:rPr lang="en-US" sz="1950" b="1" spc="222" kern="0" dirty="0">
+                <a:solidFill>
+                  <a:srgbClr val="6B6A66"/>
+                </a:solidFill>
+                <a:latin typeface="Be Vietnam Pro" pitchFamily="34" charset="0"/>
+                <a:ea typeface="Be Vietnam Pro" pitchFamily="34" charset="-122"/>
+                <a:cs typeface="Be Vietnam Pro" pitchFamily="34" charset="-120"/>
+              </a:rPr>
+              <a:t> 2</a:t>
+            </a:r>
+            <a:r>
+              <a:rPr lang="en-US" sz="1950" b="1" spc="221" kern="0" dirty="0">
+                <a:solidFill>
+                  <a:srgbClr val="6B6A66"/>
+                </a:solidFill>
+                <a:latin typeface="Be Vietnam Pro" pitchFamily="34" charset="0"/>
+                <a:ea typeface="Be Vietnam Pro" pitchFamily="34" charset="-122"/>
+                <a:cs typeface="Be Vietnam Pro" pitchFamily="34" charset="-120"/>
+              </a:rPr>
+              <a:t> ·</a:t>
+            </a:r>
+            <a:r>
+              <a:rPr lang="en-US" sz="1950" b="1" spc="226" kern="0" dirty="0">
+                <a:solidFill>
+                  <a:srgbClr val="6B6A66"/>
+                </a:solidFill>
+                <a:latin typeface="Be Vietnam Pro" pitchFamily="34" charset="0"/>
+                <a:ea typeface="Be Vietnam Pro" pitchFamily="34" charset="-122"/>
+                <a:cs typeface="Be Vietnam Pro" pitchFamily="34" charset="-120"/>
+              </a:rPr>
+              <a:t> HAI</a:t>
             </a:r>
             <a:r>
               <a:rPr lang="en-US" sz="1950" b="1" spc="225" kern="0" dirty="0">
@@ -6268,7 +6472,7 @@
               <a:t> RO</a:t>
             </a:r>
             <a:r>
-              <a:rPr lang="en-US" sz="1950" b="1" spc="297" kern="0" dirty="0">
+              <a:rPr lang="en-US" sz="1950" b="1" spc="300" kern="0" dirty="0">
                 <a:solidFill>
                   <a:srgbClr val="FFB454"/>
                 </a:solidFill>
@@ -6276,7 +6480,7 @@
                 <a:ea typeface="Be Vietnam Pro" pitchFamily="34" charset="-122"/>
                 <a:cs typeface="Be Vietnam Pro" pitchFamily="34" charset="-120"/>
               </a:rPr>
-              <a:t> 2</a:t>
+              <a:t> 3</a:t>
             </a:r>
             <a:endParaRPr lang="en-US" sz="1950" dirty="0"/>
           </a:p>
@@ -7299,7 +7503,7 @@
               <a:t> RO</a:t>
             </a:r>
             <a:r>
-              <a:rPr lang="en-US" sz="1950" b="1" spc="300" kern="0" dirty="0">
+              <a:rPr lang="en-US" sz="1950" b="1" spc="301" kern="0" dirty="0">
                 <a:solidFill>
                   <a:srgbClr val="0F766E"/>
                 </a:solidFill>
@@ -7307,7 +7511,7 @@
                 <a:ea typeface="Be Vietnam Pro" pitchFamily="34" charset="-122"/>
                 <a:cs typeface="Be Vietnam Pro" pitchFamily="34" charset="-120"/>
               </a:rPr>
-              <a:t> 3</a:t>
+              <a:t> 4</a:t>
             </a:r>
             <a:endParaRPr lang="en-US" sz="1950" dirty="0"/>
           </a:p>
@@ -8136,7 +8340,7 @@
               <a:t> RO</a:t>
             </a:r>
             <a:r>
-              <a:rPr lang="en-US" sz="1950" b="1" spc="301" kern="0" dirty="0">
+              <a:rPr lang="en-US" sz="1950" b="1" spc="302" kern="0" dirty="0">
                 <a:solidFill>
                   <a:srgbClr val="FF6A4D"/>
                 </a:solidFill>
@@ -8144,7 +8348,7 @@
                 <a:ea typeface="Be Vietnam Pro" pitchFamily="34" charset="-122"/>
                 <a:cs typeface="Be Vietnam Pro" pitchFamily="34" charset="-120"/>
               </a:rPr>
-              <a:t> 4</a:t>
+              <a:t> 5</a:t>
             </a:r>
             <a:endParaRPr lang="en-US" sz="1950" dirty="0"/>
           </a:p>

</xml_diff>

<commit_message>
Slides: keep the nonempty and empty table cases apart (sd-13-020)
Co-Authored-By: Claude Sonnet 5.5 <noreply@anthropic.com>
Claude-Session: https://claude.ai/code/session_01EhxTYrCJpuk4mcqCLwPdds
</commit_message>
<xml_diff>
--- a/system-design-101/vi/lessons/sd-13-020/slides/sd-13-020.pptx
+++ b/system-design-101/vi/lessons/sd-13-020/slides/sd-13-020.pptx
@@ -10582,7 +10582,7 @@
         <p:spPr>
           <a:xfrm>
             <a:off x="914400" y="2047875"/>
-            <a:ext cx="16459200" cy="1619250"/>
+            <a:ext cx="16459200" cy="1809750"/>
           </a:xfrm>
           <a:prstGeom prst="rect">
             <a:avLst/>
@@ -10598,7 +10598,7 @@
               <a:buNone/>
             </a:pPr>
             <a:r>
-              <a:rPr lang="en-US" sz="2850" dirty="0" spc="0" kern="0">
+              <a:rPr lang="en-US" sz="2550" dirty="0" spc="-3" kern="0">
                 <a:solidFill>
                   <a:srgbClr val="E4E1D8"/>
                 </a:solidFill>
@@ -10609,7 +10609,7 @@
               <a:t>Có</a:t>
             </a:r>
             <a:r>
-              <a:rPr lang="en-US" sz="2850" dirty="0" spc="4" kern="0">
+              <a:rPr lang="en-US" sz="2550" dirty="0" spc="-2" kern="0">
                 <a:solidFill>
                   <a:srgbClr val="E4E1D8"/>
                 </a:solidFill>
@@ -10620,7 +10620,7 @@
               <a:t> mặc</a:t>
             </a:r>
             <a:r>
-              <a:rPr lang="en-US" sz="2850" dirty="0" spc="15" kern="0">
+              <a:rPr lang="en-US" sz="2550" dirty="0" spc="16" kern="0">
                 <a:solidFill>
                   <a:srgbClr val="E4E1D8"/>
                 </a:solidFill>
@@ -10631,7 +10631,7 @@
               <a:t> định:</a:t>
             </a:r>
             <a:r>
-              <a:rPr lang="en-US" sz="2850" dirty="0" spc="-1" kern="0">
+              <a:rPr lang="en-US" sz="2550" dirty="0" spc="-3" kern="0">
                 <a:solidFill>
                   <a:srgbClr val="E4E1D8"/>
                 </a:solidFill>
@@ -10642,7 +10642,7 @@
               <a:t> bản</a:t>
             </a:r>
             <a:r>
-              <a:rPr lang="en-US" sz="2850" dirty="0" spc="4" kern="0">
+              <a:rPr lang="en-US" sz="2550" dirty="0" spc="1" kern="0">
                 <a:solidFill>
                   <a:srgbClr val="E4E1D8"/>
                 </a:solidFill>
@@ -10653,7 +10653,7 @@
               <a:t> cũ</a:t>
             </a:r>
             <a:r>
-              <a:rPr lang="en-US" sz="2850" dirty="0" spc="-14" kern="0">
+              <a:rPr lang="en-US" sz="2550" dirty="0" spc="-14" kern="0">
                 <a:solidFill>
                   <a:srgbClr val="E4E1D8"/>
                 </a:solidFill>
@@ -10664,7 +10664,7 @@
               <a:t> vẫn</a:t>
             </a:r>
             <a:r>
-              <a:rPr lang="en-US" sz="2850" dirty="0" spc="1" kern="0">
+              <a:rPr lang="en-US" sz="2550" dirty="0" spc="3" kern="0">
                 <a:solidFill>
                   <a:srgbClr val="E4E1D8"/>
                 </a:solidFill>
@@ -10675,7 +10675,7 @@
               <a:t> ghi</a:t>
             </a:r>
             <a:r>
-              <a:rPr lang="en-US" sz="2850" dirty="0" spc="9" kern="0">
+              <a:rPr lang="en-US" sz="2550" dirty="0" spc="8" kern="0">
                 <a:solidFill>
                   <a:srgbClr val="E4E1D8"/>
                 </a:solidFill>
@@ -10685,14 +10685,14 @@
               </a:rPr>
               <a:t> được.</a:t>
             </a:r>
-            <a:endParaRPr lang="en-US" sz="2850" dirty="0"/>
+            <a:endParaRPr lang="en-US" sz="2550" dirty="0"/>
           </a:p>
           <a:p>
             <a:pPr algn="l" indent="0" marL="0">
               <a:buNone/>
             </a:pPr>
             <a:r>
-              <a:rPr lang="en-US" sz="2850" dirty="0" spc="-9" kern="0">
+              <a:rPr lang="en-US" sz="2550" dirty="0" spc="-3" kern="0">
                 <a:solidFill>
                   <a:srgbClr val="E4E1D8"/>
                 </a:solidFill>
@@ -10703,7 +10703,7 @@
               <a:t>Không</a:t>
             </a:r>
             <a:r>
-              <a:rPr lang="en-US" sz="2850" dirty="0" spc="4" kern="0">
+              <a:rPr lang="en-US" sz="2550" dirty="0" spc="-1" kern="0">
                 <a:solidFill>
                   <a:srgbClr val="E4E1D8"/>
                 </a:solidFill>
@@ -10714,7 +10714,7 @@
               <a:t> mặc</a:t>
             </a:r>
             <a:r>
-              <a:rPr lang="en-US" sz="2850" dirty="0" spc="15" kern="0">
+              <a:rPr lang="en-US" sz="2550" dirty="0" spc="14" kern="0">
                 <a:solidFill>
                   <a:srgbClr val="E4E1D8"/>
                 </a:solidFill>
@@ -10722,10 +10722,10 @@
                 <a:ea typeface="Be Vietnam Pro SemiBold" pitchFamily="34" charset="-122"/>
                 <a:cs typeface="Be Vietnam Pro SemiBold" pitchFamily="34" charset="-120"/>
               </a:rPr>
-              <a:t> định:</a:t>
-            </a:r>
-            <a:r>
-              <a:rPr lang="en-US" sz="2850" dirty="0" spc="-2" kern="0">
+              <a:t> định,</a:t>
+            </a:r>
+            <a:r>
+              <a:rPr lang="en-US" sz="2550" dirty="0" spc="-2" kern="0">
                 <a:solidFill>
                   <a:srgbClr val="E4E1D8"/>
                 </a:solidFill>
@@ -10733,10 +10733,10 @@
                 <a:ea typeface="Be Vietnam Pro SemiBold" pitchFamily="34" charset="-122"/>
                 <a:cs typeface="Be Vietnam Pro SemiBold" pitchFamily="34" charset="-120"/>
               </a:rPr>
-              <a:t> lỗi;</a:t>
-            </a:r>
-            <a:r>
-              <a:rPr lang="en-US" sz="2850" dirty="0" spc="-15" kern="0">
+              <a:t> bảng</a:t>
+            </a:r>
+            <a:r>
+              <a:rPr lang="en-US" sz="2550" dirty="0" spc="9" kern="0">
                 <a:solidFill>
                   <a:srgbClr val="E4E1D8"/>
                 </a:solidFill>
@@ -10744,10 +10744,10 @@
                 <a:ea typeface="Be Vietnam Pro SemiBold" pitchFamily="34" charset="-122"/>
                 <a:cs typeface="Be Vietnam Pro SemiBold" pitchFamily="34" charset="-120"/>
               </a:rPr>
-              <a:t> PostgreSQL</a:t>
-            </a:r>
-            <a:r>
-              <a:rPr lang="en-US" sz="2850" dirty="0" spc="1" kern="0">
+              <a:t> đã</a:t>
+            </a:r>
+            <a:r>
+              <a:rPr lang="en-US" sz="2550" dirty="0" spc="-4" kern="0">
                 <a:solidFill>
                   <a:srgbClr val="E4E1D8"/>
                 </a:solidFill>
@@ -10755,10 +10755,10 @@
                 <a:ea typeface="Be Vietnam Pro SemiBold" pitchFamily="34" charset="-122"/>
                 <a:cs typeface="Be Vietnam Pro SemiBold" pitchFamily="34" charset="-120"/>
               </a:rPr>
-              <a:t> từ</a:t>
-            </a:r>
-            <a:r>
-              <a:rPr lang="en-US" sz="2850" dirty="0" spc="-2" kern="0">
+              <a:t> có dòng:</a:t>
+            </a:r>
+            <a:r>
+              <a:rPr lang="en-US" sz="2550" dirty="0" spc="-11" kern="0">
                 <a:solidFill>
                   <a:srgbClr val="E4E1D8"/>
                 </a:solidFill>
@@ -10766,10 +10766,10 @@
                 <a:ea typeface="Be Vietnam Pro SemiBold" pitchFamily="34" charset="-122"/>
                 <a:cs typeface="Be Vietnam Pro SemiBold" pitchFamily="34" charset="-120"/>
               </a:rPr>
-              <a:t> chối</a:t>
-            </a:r>
-            <a:r>
-              <a:rPr lang="en-US" sz="2850" dirty="0" spc="-17" kern="0">
+              <a:t> migration</a:t>
+            </a:r>
+            <a:r>
+              <a:rPr lang="en-US" sz="2550" dirty="0" spc="0" kern="0">
                 <a:solidFill>
                   <a:srgbClr val="E4E1D8"/>
                 </a:solidFill>
@@ -10777,10 +10777,10 @@
                 <a:ea typeface="Be Vietnam Pro SemiBold" pitchFamily="34" charset="-122"/>
                 <a:cs typeface="Be Vietnam Pro SemiBold" pitchFamily="34" charset="-120"/>
               </a:rPr>
-              <a:t> ngay</a:t>
-            </a:r>
-            <a:r>
-              <a:rPr lang="en-US" sz="2850" dirty="0" spc="-1" kern="0">
+              <a:t> bị</a:t>
+            </a:r>
+            <a:r>
+              <a:rPr lang="en-US" sz="2550" dirty="0" spc="-2" kern="0">
                 <a:solidFill>
                   <a:srgbClr val="E4E1D8"/>
                 </a:solidFill>
@@ -10788,10 +10788,10 @@
                 <a:ea typeface="Be Vietnam Pro SemiBold" pitchFamily="34" charset="-122"/>
                 <a:cs typeface="Be Vietnam Pro SemiBold" pitchFamily="34" charset="-120"/>
               </a:rPr>
-              <a:t> ở</a:t>
-            </a:r>
-            <a:r>
-              <a:rPr lang="en-US" sz="2850" dirty="0" spc="-13" kern="0">
+              <a:t> từ</a:t>
+            </a:r>
+            <a:r>
+              <a:rPr lang="en-US" sz="2550" dirty="0" spc="-1" kern="0">
                 <a:solidFill>
                   <a:srgbClr val="E4E1D8"/>
                 </a:solidFill>
@@ -10799,16 +10799,16 @@
                 <a:ea typeface="Be Vietnam Pro SemiBold" pitchFamily="34" charset="-122"/>
                 <a:cs typeface="Be Vietnam Pro SemiBold" pitchFamily="34" charset="-120"/>
               </a:rPr>
-              <a:t> migration.</a:t>
-            </a:r>
-            <a:endParaRPr lang="en-US" sz="2850" dirty="0"/>
+              <a:t> chối.</a:t>
+            </a:r>
+            <a:endParaRPr lang="en-US" sz="2550" dirty="0"/>
           </a:p>
           <a:p>
             <a:pPr algn="l" indent="0" marL="0">
               <a:buNone/>
             </a:pPr>
             <a:r>
-              <a:rPr lang="en-US" sz="2850" dirty="0" spc="-4" kern="0">
+              <a:rPr lang="en-US" sz="2550" dirty="0" spc="-3" kern="0">
                 <a:solidFill>
                   <a:srgbClr val="E4E1D8"/>
                 </a:solidFill>
@@ -10816,10 +10816,10 @@
                 <a:ea typeface="Be Vietnam Pro SemiBold" pitchFamily="34" charset="-122"/>
                 <a:cs typeface="Be Vietnam Pro SemiBold" pitchFamily="34" charset="-120"/>
               </a:rPr>
-              <a:t>An</a:t>
-            </a:r>
-            <a:r>
-              <a:rPr lang="en-US" sz="2850" dirty="0" spc="-8" kern="0">
+              <a:t>Không</a:t>
+            </a:r>
+            <a:r>
+              <a:rPr lang="en-US" sz="2550" dirty="0" spc="-1" kern="0">
                 <a:solidFill>
                   <a:srgbClr val="E4E1D8"/>
                 </a:solidFill>
@@ -10827,10 +10827,10 @@
                 <a:ea typeface="Be Vietnam Pro SemiBold" pitchFamily="34" charset="-122"/>
                 <a:cs typeface="Be Vietnam Pro SemiBold" pitchFamily="34" charset="-120"/>
               </a:rPr>
-              <a:t> toàn nhất:</a:t>
-            </a:r>
-            <a:r>
-              <a:rPr lang="en-US" sz="2850" dirty="0" spc="-4" kern="0">
+              <a:t> mặc</a:t>
+            </a:r>
+            <a:r>
+              <a:rPr lang="en-US" sz="2550" dirty="0" spc="14" kern="0">
                 <a:solidFill>
                   <a:srgbClr val="E4E1D8"/>
                 </a:solidFill>
@@ -10838,10 +10838,10 @@
                 <a:ea typeface="Be Vietnam Pro SemiBold" pitchFamily="34" charset="-122"/>
                 <a:cs typeface="Be Vietnam Pro SemiBold" pitchFamily="34" charset="-120"/>
               </a:rPr>
-              <a:t> mở</a:t>
-            </a:r>
-            <a:r>
-              <a:rPr lang="en-US" sz="2850" dirty="0" spc="-22" kern="0">
+              <a:t> định,</a:t>
+            </a:r>
+            <a:r>
+              <a:rPr lang="en-US" sz="2550" dirty="0" spc="-2" kern="0">
                 <a:solidFill>
                   <a:srgbClr val="E4E1D8"/>
                 </a:solidFill>
@@ -10849,10 +10849,10 @@
                 <a:ea typeface="Be Vietnam Pro SemiBold" pitchFamily="34" charset="-122"/>
                 <a:cs typeface="Be Vietnam Pro SemiBold" pitchFamily="34" charset="-120"/>
               </a:rPr>
-              <a:t> rộng</a:t>
-            </a:r>
-            <a:r>
-              <a:rPr lang="en-US" sz="2850" dirty="0" spc="-20" kern="0">
+              <a:t> bảng</a:t>
+            </a:r>
+            <a:r>
+              <a:rPr lang="en-US" sz="2550" dirty="0" spc="-14" kern="0">
                 <a:solidFill>
                   <a:srgbClr val="E4E1D8"/>
                 </a:solidFill>
@@ -10860,10 +10860,10 @@
                 <a:ea typeface="Be Vietnam Pro SemiBold" pitchFamily="34" charset="-122"/>
                 <a:cs typeface="Be Vietnam Pro SemiBold" pitchFamily="34" charset="-120"/>
               </a:rPr>
-              <a:t> rồi</a:t>
-            </a:r>
-            <a:r>
-              <a:rPr lang="en-US" sz="2850" dirty="0" spc="2" kern="0">
+              <a:t> rỗng:</a:t>
+            </a:r>
+            <a:r>
+              <a:rPr lang="en-US" sz="2550" dirty="0" spc="-3" kern="0">
                 <a:solidFill>
                   <a:srgbClr val="E4E1D8"/>
                 </a:solidFill>
@@ -10871,10 +10871,10 @@
                 <a:ea typeface="Be Vietnam Pro SemiBold" pitchFamily="34" charset="-122"/>
                 <a:cs typeface="Be Vietnam Pro SemiBold" pitchFamily="34" charset="-120"/>
               </a:rPr>
-              <a:t> thu</a:t>
-            </a:r>
-            <a:r>
-              <a:rPr lang="en-US" sz="2850" dirty="0" spc="-11" kern="0">
+              <a:t> bản</a:t>
+            </a:r>
+            <a:r>
+              <a:rPr lang="en-US" sz="2550" dirty="0" spc="1" kern="0">
                 <a:solidFill>
                   <a:srgbClr val="E4E1D8"/>
                 </a:solidFill>
@@ -10882,9 +10882,125 @@
                 <a:ea typeface="Be Vietnam Pro SemiBold" pitchFamily="34" charset="-122"/>
                 <a:cs typeface="Be Vietnam Pro SemiBold" pitchFamily="34" charset="-120"/>
               </a:rPr>
+              <a:t> cũ</a:t>
+            </a:r>
+            <a:r>
+              <a:rPr lang="en-US" sz="2550" dirty="0" spc="3" kern="0">
+                <a:solidFill>
+                  <a:srgbClr val="E4E1D8"/>
+                </a:solidFill>
+                <a:latin typeface="Be Vietnam Pro SemiBold" pitchFamily="34" charset="0"/>
+                <a:ea typeface="Be Vietnam Pro SemiBold" pitchFamily="34" charset="-122"/>
+                <a:cs typeface="Be Vietnam Pro SemiBold" pitchFamily="34" charset="-120"/>
+              </a:rPr>
+              <a:t> ghi</a:t>
+            </a:r>
+            <a:r>
+              <a:rPr lang="en-US" sz="2550" dirty="0" spc="-4" kern="0">
+                <a:solidFill>
+                  <a:srgbClr val="E4E1D8"/>
+                </a:solidFill>
+                <a:latin typeface="Be Vietnam Pro SemiBold" pitchFamily="34" charset="0"/>
+                <a:ea typeface="Be Vietnam Pro SemiBold" pitchFamily="34" charset="-122"/>
+                <a:cs typeface="Be Vietnam Pro SemiBold" pitchFamily="34" charset="-120"/>
+              </a:rPr>
+              <a:t> lỗi sau.</a:t>
+            </a:r>
+            <a:endParaRPr lang="en-US" sz="2550" dirty="0"/>
+          </a:p>
+          <a:p>
+            <a:pPr algn="l" indent="0" marL="0">
+              <a:buNone/>
+            </a:pPr>
+            <a:r>
+              <a:rPr lang="en-US" sz="2550" dirty="0" spc="0" kern="0">
+                <a:solidFill>
+                  <a:srgbClr val="E4E1D8"/>
+                </a:solidFill>
+                <a:latin typeface="Be Vietnam Pro SemiBold" pitchFamily="34" charset="0"/>
+                <a:ea typeface="Be Vietnam Pro SemiBold" pitchFamily="34" charset="-122"/>
+                <a:cs typeface="Be Vietnam Pro SemiBold" pitchFamily="34" charset="-120"/>
+              </a:rPr>
+              <a:t>An</a:t>
+            </a:r>
+            <a:r>
+              <a:rPr lang="en-US" sz="2550" dirty="0" spc="-9" kern="0">
+                <a:solidFill>
+                  <a:srgbClr val="E4E1D8"/>
+                </a:solidFill>
+                <a:latin typeface="Be Vietnam Pro SemiBold" pitchFamily="34" charset="0"/>
+                <a:ea typeface="Be Vietnam Pro SemiBold" pitchFamily="34" charset="-122"/>
+                <a:cs typeface="Be Vietnam Pro SemiBold" pitchFamily="34" charset="-120"/>
+              </a:rPr>
+              <a:t> toàn</a:t>
+            </a:r>
+            <a:r>
+              <a:rPr lang="en-US" sz="2550" dirty="0" spc="-7" kern="0">
+                <a:solidFill>
+                  <a:srgbClr val="E4E1D8"/>
+                </a:solidFill>
+                <a:latin typeface="Be Vietnam Pro SemiBold" pitchFamily="34" charset="0"/>
+                <a:ea typeface="Be Vietnam Pro SemiBold" pitchFamily="34" charset="-122"/>
+                <a:cs typeface="Be Vietnam Pro SemiBold" pitchFamily="34" charset="-120"/>
+              </a:rPr>
+              <a:t> nhất:</a:t>
+            </a:r>
+            <a:r>
+              <a:rPr lang="en-US" sz="2550" dirty="0" spc="-6" kern="0">
+                <a:solidFill>
+                  <a:srgbClr val="E4E1D8"/>
+                </a:solidFill>
+                <a:latin typeface="Be Vietnam Pro SemiBold" pitchFamily="34" charset="0"/>
+                <a:ea typeface="Be Vietnam Pro SemiBold" pitchFamily="34" charset="-122"/>
+                <a:cs typeface="Be Vietnam Pro SemiBold" pitchFamily="34" charset="-120"/>
+              </a:rPr>
+              <a:t> mở</a:t>
+            </a:r>
+            <a:r>
+              <a:rPr lang="en-US" sz="2550" dirty="0" spc="-17" kern="0">
+                <a:solidFill>
+                  <a:srgbClr val="E4E1D8"/>
+                </a:solidFill>
+                <a:latin typeface="Be Vietnam Pro SemiBold" pitchFamily="34" charset="0"/>
+                <a:ea typeface="Be Vietnam Pro SemiBold" pitchFamily="34" charset="-122"/>
+                <a:cs typeface="Be Vietnam Pro SemiBold" pitchFamily="34" charset="-120"/>
+              </a:rPr>
+              <a:t> rộng</a:t>
+            </a:r>
+            <a:r>
+              <a:rPr lang="en-US" sz="2550" dirty="0" spc="-19" kern="0">
+                <a:solidFill>
+                  <a:srgbClr val="E4E1D8"/>
+                </a:solidFill>
+                <a:latin typeface="Be Vietnam Pro SemiBold" pitchFamily="34" charset="0"/>
+                <a:ea typeface="Be Vietnam Pro SemiBold" pitchFamily="34" charset="-122"/>
+                <a:cs typeface="Be Vietnam Pro SemiBold" pitchFamily="34" charset="-120"/>
+              </a:rPr>
+              <a:t> rồi</a:t>
+            </a:r>
+            <a:r>
+              <a:rPr lang="en-US" sz="2550" dirty="0" spc="-2" kern="0">
+                <a:solidFill>
+                  <a:srgbClr val="E4E1D8"/>
+                </a:solidFill>
+                <a:latin typeface="Be Vietnam Pro SemiBold" pitchFamily="34" charset="0"/>
+                <a:ea typeface="Be Vietnam Pro SemiBold" pitchFamily="34" charset="-122"/>
+                <a:cs typeface="Be Vietnam Pro SemiBold" pitchFamily="34" charset="-120"/>
+              </a:rPr>
+              <a:t> thu</a:t>
+            </a:r>
+            <a:r>
+              <a:rPr lang="en-US" sz="2550" dirty="0" spc="-7" kern="0">
+                <a:solidFill>
+                  <a:srgbClr val="E4E1D8"/>
+                </a:solidFill>
+                <a:latin typeface="Be Vietnam Pro SemiBold" pitchFamily="34" charset="0"/>
+                <a:ea typeface="Be Vietnam Pro SemiBold" pitchFamily="34" charset="-122"/>
+                <a:cs typeface="Be Vietnam Pro SemiBold" pitchFamily="34" charset="-120"/>
+              </a:rPr>
               <a:t> gọn.</a:t>
             </a:r>
-            <a:endParaRPr lang="en-US" sz="2850" dirty="0"/>
+            <a:endParaRPr lang="en-US" sz="2550" dirty="0"/>
           </a:p>
         </p:txBody>
       </p:sp>

</xml_diff>

<commit_message>
Slides: name PostgreSQL as the database of the column example (sd-13-020)
Co-Authored-By: Claude Sonnet 5.5 <noreply@anthropic.com>
Claude-Session: https://claude.ai/code/session_01EhxTYrCJpuk4mcqCLwPdds
</commit_message>
<xml_diff>
--- a/system-design-101/vi/lessons/sd-13-020/slides/sd-13-020.pptx
+++ b/system-design-101/vi/lessons/sd-13-020/slides/sd-13-020.pptx
@@ -10322,6 +10322,83 @@
               <a:buNone/>
             </a:pPr>
             <a:r>
+              <a:rPr lang="en-US" sz="1950" b="1" spc="304" kern="0" dirty="0">
+                <a:solidFill>
+                  <a:srgbClr val="7C93FF"/>
+                </a:solidFill>
+                <a:latin typeface="Be Vietnam Pro" pitchFamily="34" charset="0"/>
+                <a:ea typeface="Be Vietnam Pro" pitchFamily="34" charset="-122"/>
+                <a:cs typeface="Be Vietnam Pro" pitchFamily="34" charset="-120"/>
+              </a:rPr>
+              <a:t>VÍ</a:t>
+            </a:r>
+            <a:r>
+              <a:rPr lang="en-US" sz="1950" b="1" spc="302" kern="0" dirty="0">
+                <a:solidFill>
+                  <a:srgbClr val="7C93FF"/>
+                </a:solidFill>
+                <a:latin typeface="Be Vietnam Pro" pitchFamily="34" charset="0"/>
+                <a:ea typeface="Be Vietnam Pro" pitchFamily="34" charset="-122"/>
+                <a:cs typeface="Be Vietnam Pro" pitchFamily="34" charset="-120"/>
+              </a:rPr>
+              <a:t> DỤ</a:t>
+            </a:r>
+            <a:r>
+              <a:rPr lang="en-US" sz="1950" b="1" spc="290" kern="0" dirty="0">
+                <a:solidFill>
+                  <a:srgbClr val="7C93FF"/>
+                </a:solidFill>
+                <a:latin typeface="Be Vietnam Pro" pitchFamily="34" charset="0"/>
+                <a:ea typeface="Be Vietnam Pro" pitchFamily="34" charset="-122"/>
+                <a:cs typeface="Be Vietnam Pro" pitchFamily="34" charset="-120"/>
+              </a:rPr>
+              <a:t> POSTGRESQL</a:t>
+            </a:r>
+            <a:r>
+              <a:rPr lang="en-US" sz="1950" b="1" spc="298" kern="0" dirty="0">
+                <a:solidFill>
+                  <a:srgbClr val="7C93FF"/>
+                </a:solidFill>
+                <a:latin typeface="Be Vietnam Pro" pitchFamily="34" charset="0"/>
+                <a:ea typeface="Be Vietnam Pro" pitchFamily="34" charset="-122"/>
+                <a:cs typeface="Be Vietnam Pro" pitchFamily="34" charset="-120"/>
+              </a:rPr>
+              <a:t> ·</a:t>
+            </a:r>
+            <a:r>
+              <a:rPr lang="en-US" sz="1950" b="1" spc="299" kern="0" dirty="0">
+                <a:solidFill>
+                  <a:srgbClr val="7C93FF"/>
+                </a:solidFill>
+                <a:latin typeface="Be Vietnam Pro" pitchFamily="34" charset="0"/>
+                <a:ea typeface="Be Vietnam Pro" pitchFamily="34" charset="-122"/>
+                <a:cs typeface="Be Vietnam Pro" pitchFamily="34" charset="-120"/>
+              </a:rPr>
+              <a:t> CƠ</a:t>
+            </a:r>
+            <a:r>
+              <a:rPr lang="en-US" sz="1950" b="1" spc="307" kern="0" dirty="0">
+                <a:solidFill>
+                  <a:srgbClr val="7C93FF"/>
+                </a:solidFill>
+                <a:latin typeface="Be Vietnam Pro" pitchFamily="34" charset="0"/>
+                <a:ea typeface="Be Vietnam Pro" pitchFamily="34" charset="-122"/>
+                <a:cs typeface="Be Vietnam Pro" pitchFamily="34" charset="-120"/>
+              </a:rPr>
+              <a:t> SỞ</a:t>
+            </a:r>
+            <a:r>
+              <a:rPr lang="en-US" sz="1950" b="1" spc="302" kern="0" dirty="0">
+                <a:solidFill>
+                  <a:srgbClr val="7C93FF"/>
+                </a:solidFill>
+                <a:latin typeface="Be Vietnam Pro" pitchFamily="34" charset="0"/>
+                <a:ea typeface="Be Vietnam Pro" pitchFamily="34" charset="-122"/>
+                <a:cs typeface="Be Vietnam Pro" pitchFamily="34" charset="-120"/>
+              </a:rPr>
+              <a:t> DỮ</a:t>
+            </a:r>
+            <a:r>
               <a:rPr lang="en-US" sz="1950" b="1" spc="301" kern="0" dirty="0">
                 <a:solidFill>
                   <a:srgbClr val="7C93FF"/>
@@ -10330,10 +10407,10 @@
                 <a:ea typeface="Be Vietnam Pro" pitchFamily="34" charset="-122"/>
                 <a:cs typeface="Be Vietnam Pro" pitchFamily="34" charset="-120"/>
               </a:rPr>
-              <a:t>NHÌN</a:t>
-            </a:r>
-            <a:r>
-              <a:rPr lang="en-US" sz="1950" b="1" spc="302" kern="0" dirty="0">
+              <a:t> LIỆU</a:t>
+            </a:r>
+            <a:r>
+              <a:rPr lang="en-US" sz="1950" b="1" spc="285" kern="0" dirty="0">
                 <a:solidFill>
                   <a:srgbClr val="7C93FF"/>
                 </a:solidFill>
@@ -10341,10 +10418,10 @@
                 <a:ea typeface="Be Vietnam Pro" pitchFamily="34" charset="-122"/>
                 <a:cs typeface="Be Vietnam Pro" pitchFamily="34" charset="-120"/>
               </a:rPr>
-              <a:t> HÌNH</a:t>
-            </a:r>
-            <a:r>
-              <a:rPr lang="en-US" sz="1950" b="1" spc="301" kern="0" dirty="0">
+              <a:t> KHÁC</a:t>
+            </a:r>
+            <a:r>
+              <a:rPr lang="en-US" sz="1950" b="1" spc="299" kern="0" dirty="0">
                 <a:solidFill>
                   <a:srgbClr val="7C93FF"/>
                 </a:solidFill>
@@ -10352,7 +10429,7 @@
                 <a:ea typeface="Be Vietnam Pro" pitchFamily="34" charset="-122"/>
                 <a:cs typeface="Be Vietnam Pro" pitchFamily="34" charset="-120"/>
               </a:rPr>
-              <a:t> THỬ</a:t>
+              <a:t> CÓ</a:t>
             </a:r>
             <a:r>
               <a:rPr lang="en-US" sz="1950" b="1" spc="300" kern="0" dirty="0">
@@ -10363,10 +10440,10 @@
                 <a:ea typeface="Be Vietnam Pro" pitchFamily="34" charset="-122"/>
                 <a:cs typeface="Be Vietnam Pro" pitchFamily="34" charset="-120"/>
               </a:rPr>
-              <a:t> TRẢ</a:t>
-            </a:r>
-            <a:r>
-              <a:rPr lang="en-US" sz="1950" b="1" spc="279" kern="0" dirty="0">
+              <a:t> THỂ</a:t>
+            </a:r>
+            <a:r>
+              <a:rPr lang="en-US" sz="1950" b="1" spc="285" kern="0" dirty="0">
                 <a:solidFill>
                   <a:srgbClr val="7C93FF"/>
                 </a:solidFill>
@@ -10374,7 +10451,7 @@
                 <a:ea typeface="Be Vietnam Pro" pitchFamily="34" charset="-122"/>
                 <a:cs typeface="Be Vietnam Pro" pitchFamily="34" charset="-120"/>
               </a:rPr>
-              <a:t> LỜI</a:t>
+              <a:t> KHÁC</a:t>
             </a:r>
             <a:endParaRPr lang="en-US" sz="1950" dirty="0"/>
           </a:p>

</xml_diff>